<commit_message>
Enlazar diapo 4 con productividad: las dos palancas como guion
La tarjeta Acciones muestra palanca 1 (productividad) y palanca 2
(áreas) como proceso vertical; una franja anuncia el guion; la diapo
de operativa explica el porqué y los separadores pasan de Bloque a
Palanca 1/2.

https://claude.ai/code/session_01Hy8gcRrxHqQ4mNDt67yRZD
</commit_message>
<xml_diff>
--- a/Proyecto_Personal_OSRM_v2.pptx
+++ b/Proyecto_Personal_OSRM_v2.pptx
@@ -3051,7 +3051,7 @@
                 <a:ea typeface="Courier New" pitchFamily="34" charset="-122"/>
                 <a:cs typeface="Courier New" pitchFamily="34" charset="-120"/>
               </a:rPr>
-              <a:t>BLOQUE 2 · ÁREAS</a:t>
+              <a:t>PALANCA 2 · ÁREAS</a:t>
             </a:r>
             <a:endParaRPr lang="en-US" sz="1800" dirty="0"/>
           </a:p>
@@ -5624,7 +5624,7 @@
                 <a:ea typeface="Courier New" pitchFamily="34" charset="-122"/>
                 <a:cs typeface="Courier New" pitchFamily="34" charset="-120"/>
               </a:rPr>
-              <a:t>BLOQUE 2 · LA HERRAMIENTA</a:t>
+              <a:t>PALANCA 2 · LA HERRAMIENTA</a:t>
             </a:r>
             <a:endParaRPr lang="en-US" sz="1800" dirty="0"/>
           </a:p>
@@ -15131,7 +15131,7 @@
                 <a:ea typeface="Arial" pitchFamily="34" charset="-122"/>
                 <a:cs typeface="Arial" pitchFamily="34" charset="-120"/>
               </a:rPr>
-              <a:t>tablas · coordenadas de entrega · demanda</a:t>
+              <a:t>tablas · coordenadas · demanda</a:t>
             </a:r>
             <a:endParaRPr lang="en-US" sz="1500" dirty="0"/>
           </a:p>
@@ -15441,14 +15441,44 @@
       </p:sp>
       <p:sp>
         <p:nvSpPr>
-          <p:cNvPr id="19" name="Text 19"/>
-          <p:cNvSpPr/>
-          <p:nvPr/>
-        </p:nvSpPr>
-        <p:spPr>
-          <a:xfrm>
-            <a:off x="7165594" y="5500000"/>
-            <a:ext cx="4441444" cy="352425"/>
+          <p:cNvPr id="19" name="Shape 19"/>
+          <p:cNvSpPr/>
+          <p:nvPr/>
+        </p:nvSpPr>
+        <p:spPr>
+          <a:xfrm>
+            <a:off x="7165594" y="5100000"/>
+            <a:ext cx="4441444" cy="880000"/>
+          </a:xfrm>
+          <a:prstGeom prst="roundRect">
+            <a:avLst>
+              <a:gd name="adj" fmla="val 8000"/>
+            </a:avLst>
+          </a:prstGeom>
+          <a:solidFill>
+            <a:srgbClr val="2D7A55"/>
+          </a:solidFill>
+          <a:ln/>
+          <a:effectLst/>
+        </p:spPr>
+        <p:txBody>
+          <a:bodyPr/>
+          <a:lstStyle/>
+          <a:p>
+            <a:endParaRPr lang="es-ES"/>
+          </a:p>
+        </p:txBody>
+      </p:sp>
+      <p:sp>
+        <p:nvSpPr>
+          <p:cNvPr id="20" name="Text 20"/>
+          <p:cNvSpPr/>
+          <p:nvPr/>
+        </p:nvSpPr>
+        <p:spPr>
+          <a:xfrm>
+            <a:off x="7401744" y="5210000"/>
+            <a:ext cx="3971444" cy="380000"/>
           </a:xfrm>
           <a:prstGeom prst="rect">
             <a:avLst/>
@@ -15466,7 +15496,7 @@
               <a:buNone/>
             </a:pPr>
             <a:r>
-              <a:rPr lang="en-US" sz="2250" b="1" kern="0" dirty="0">
+              <a:rPr lang="en-US" sz="1950" b="1" kern="0" dirty="0">
                 <a:solidFill>
                   <a:srgbClr val="F4F1EA"/>
                 </a:solidFill>
@@ -15474,22 +15504,22 @@
                 <a:ea typeface="Arial" pitchFamily="34" charset="-122"/>
                 <a:cs typeface="Arial" pitchFamily="34" charset="-120"/>
               </a:rPr>
-              <a:t>Las palancas</a:t>
-            </a:r>
-            <a:endParaRPr lang="en-US" sz="2250" dirty="0"/>
-          </a:p>
-        </p:txBody>
-      </p:sp>
-      <p:sp>
-        <p:nvSpPr>
-          <p:cNvPr id="20" name="Text 20"/>
-          <p:cNvSpPr/>
-          <p:nvPr/>
-        </p:nvSpPr>
-        <p:spPr>
-          <a:xfrm>
-            <a:off x="7165594" y="5950000"/>
-            <a:ext cx="4441444" cy="1011882"/>
+              <a:t>Palanca 1 · Productividad</a:t>
+            </a:r>
+            <a:endParaRPr lang="en-US" sz="1950" dirty="0"/>
+          </a:p>
+        </p:txBody>
+      </p:sp>
+      <p:sp>
+        <p:nvSpPr>
+          <p:cNvPr id="21" name="Text 21"/>
+          <p:cNvSpPr/>
+          <p:nvPr/>
+        </p:nvSpPr>
+        <p:spPr>
+          <a:xfrm>
+            <a:off x="7401744" y="5590000"/>
+            <a:ext cx="3971444" cy="320000"/>
           </a:xfrm>
           <a:prstGeom prst="rect">
             <a:avLst/>
@@ -15504,13 +15534,10 @@
           <a:lstStyle/>
           <a:p>
             <a:pPr marL="0" indent="0" algn="l">
-              <a:lnSpc>
-                <a:spcPct val="130000"/>
-              </a:lnSpc>
-              <a:buNone/>
-            </a:pPr>
-            <a:r>
-              <a:rPr lang="en-US" sz="1800" kern="0" dirty="0">
+              <a:buNone/>
+            </a:pPr>
+            <a:r>
+              <a:rPr lang="en-US" sz="1500" kern="0" dirty="0">
                 <a:solidFill>
                   <a:srgbClr val="D7E0D8"/>
                 </a:solidFill>
@@ -15518,15 +15545,212 @@
                 <a:ea typeface="Arial" pitchFamily="34" charset="-122"/>
                 <a:cs typeface="Arial" pitchFamily="34" charset="-120"/>
               </a:rPr>
-              <a:t>Subir o bajar productividad · configurar áreas.</a:t>
-            </a:r>
-            <a:endParaRPr lang="en-US" sz="1800" dirty="0"/>
-          </a:p>
-        </p:txBody>
-      </p:sp>
-      <p:sp>
-        <p:nvSpPr>
-          <p:cNvPr id="21" name="Shape 21"/>
+              <a:t>se ajusta operativa a operativa</a:t>
+            </a:r>
+            <a:endParaRPr lang="en-US" sz="1500" dirty="0"/>
+          </a:p>
+        </p:txBody>
+      </p:sp>
+      <p:sp>
+        <p:nvSpPr>
+          <p:cNvPr id="22" name="Text 22"/>
+          <p:cNvSpPr/>
+          <p:nvPr/>
+        </p:nvSpPr>
+        <p:spPr>
+          <a:xfrm>
+            <a:off x="7165594" y="5980000"/>
+            <a:ext cx="4441444" cy="330000"/>
+          </a:xfrm>
+          <a:prstGeom prst="rect">
+            <a:avLst/>
+          </a:prstGeom>
+          <a:noFill/>
+          <a:ln/>
+        </p:spPr>
+        <p:txBody>
+          <a:bodyPr wrap="square" lIns="25400" tIns="25400" rIns="25400" bIns="25400" rtlCol="0" anchor="ctr">
+            <a:normAutofit/>
+          </a:bodyPr>
+          <a:lstStyle/>
+          <a:p>
+            <a:pPr marL="0" indent="0" algn="ctr">
+              <a:lnSpc>
+                <a:spcPct val="100000"/>
+              </a:lnSpc>
+              <a:buNone/>
+            </a:pPr>
+            <a:r>
+              <a:rPr lang="en-US" sz="2100" b="1" kern="0" dirty="0">
+                <a:solidFill>
+                  <a:srgbClr val="8FBBA6"/>
+                </a:solidFill>
+                <a:latin typeface="Arial" pitchFamily="34" charset="0"/>
+                <a:ea typeface="Arial" pitchFamily="34" charset="-122"/>
+                <a:cs typeface="Arial" pitchFamily="34" charset="-120"/>
+              </a:rPr>
+              <a:t>↓</a:t>
+            </a:r>
+            <a:endParaRPr lang="en-US" sz="2100" dirty="0"/>
+          </a:p>
+        </p:txBody>
+      </p:sp>
+      <p:sp>
+        <p:nvSpPr>
+          <p:cNvPr id="23" name="Shape 23"/>
+          <p:cNvSpPr/>
+          <p:nvPr/>
+        </p:nvSpPr>
+        <p:spPr>
+          <a:xfrm>
+            <a:off x="7165594" y="6310000"/>
+            <a:ext cx="4441444" cy="880000"/>
+          </a:xfrm>
+          <a:prstGeom prst="roundRect">
+            <a:avLst>
+              <a:gd name="adj" fmla="val 8000"/>
+            </a:avLst>
+          </a:prstGeom>
+          <a:solidFill>
+            <a:srgbClr val="2D7A55"/>
+          </a:solidFill>
+          <a:ln/>
+          <a:effectLst/>
+        </p:spPr>
+        <p:txBody>
+          <a:bodyPr/>
+          <a:lstStyle/>
+          <a:p>
+            <a:endParaRPr lang="es-ES"/>
+          </a:p>
+        </p:txBody>
+      </p:sp>
+      <p:sp>
+        <p:nvSpPr>
+          <p:cNvPr id="24" name="Text 24"/>
+          <p:cNvSpPr/>
+          <p:nvPr/>
+        </p:nvSpPr>
+        <p:spPr>
+          <a:xfrm>
+            <a:off x="7401744" y="6420000"/>
+            <a:ext cx="3971444" cy="380000"/>
+          </a:xfrm>
+          <a:prstGeom prst="rect">
+            <a:avLst/>
+          </a:prstGeom>
+          <a:noFill/>
+          <a:ln/>
+        </p:spPr>
+        <p:txBody>
+          <a:bodyPr wrap="square" lIns="25400" tIns="25400" rIns="25400" bIns="25400" rtlCol="0" anchor="t">
+            <a:normAutofit/>
+          </a:bodyPr>
+          <a:lstStyle/>
+          <a:p>
+            <a:pPr marL="0" indent="0" algn="l">
+              <a:buNone/>
+            </a:pPr>
+            <a:r>
+              <a:rPr lang="en-US" sz="1950" b="1" kern="0" dirty="0">
+                <a:solidFill>
+                  <a:srgbClr val="F4F1EA"/>
+                </a:solidFill>
+                <a:latin typeface="Arial" pitchFamily="34" charset="0"/>
+                <a:ea typeface="Arial" pitchFamily="34" charset="-122"/>
+                <a:cs typeface="Arial" pitchFamily="34" charset="-120"/>
+              </a:rPr>
+              <a:t>Palanca 2 · Áreas</a:t>
+            </a:r>
+            <a:endParaRPr lang="en-US" sz="1950" dirty="0"/>
+          </a:p>
+        </p:txBody>
+      </p:sp>
+      <p:sp>
+        <p:nvSpPr>
+          <p:cNvPr id="25" name="Text 25"/>
+          <p:cNvSpPr/>
+          <p:nvPr/>
+        </p:nvSpPr>
+        <p:spPr>
+          <a:xfrm>
+            <a:off x="7401744" y="6800000"/>
+            <a:ext cx="3971444" cy="320000"/>
+          </a:xfrm>
+          <a:prstGeom prst="rect">
+            <a:avLst/>
+          </a:prstGeom>
+          <a:noFill/>
+          <a:ln/>
+        </p:spPr>
+        <p:txBody>
+          <a:bodyPr wrap="square" lIns="25400" tIns="25400" rIns="25400" bIns="25400" rtlCol="0" anchor="t">
+            <a:normAutofit/>
+          </a:bodyPr>
+          <a:lstStyle/>
+          <a:p>
+            <a:pPr marL="0" indent="0" algn="l">
+              <a:buNone/>
+            </a:pPr>
+            <a:r>
+              <a:rPr lang="en-US" sz="1500" kern="0" dirty="0">
+                <a:solidFill>
+                  <a:srgbClr val="D7E0D8"/>
+                </a:solidFill>
+                <a:latin typeface="Arial" pitchFamily="34" charset="0"/>
+                <a:ea typeface="Arial" pitchFamily="34" charset="-122"/>
+                <a:cs typeface="Arial" pitchFamily="34" charset="-120"/>
+              </a:rPr>
+              <a:t>el margen estructural</a:t>
+            </a:r>
+            <a:endParaRPr lang="en-US" sz="1500" dirty="0"/>
+          </a:p>
+        </p:txBody>
+      </p:sp>
+      <p:sp>
+        <p:nvSpPr>
+          <p:cNvPr id="26" name="Text 26"/>
+          <p:cNvSpPr/>
+          <p:nvPr/>
+        </p:nvSpPr>
+        <p:spPr>
+          <a:xfrm>
+            <a:off x="7165594" y="7310000"/>
+            <a:ext cx="4441444" cy="320000"/>
+          </a:xfrm>
+          <a:prstGeom prst="rect">
+            <a:avLst/>
+          </a:prstGeom>
+          <a:noFill/>
+          <a:ln/>
+        </p:spPr>
+        <p:txBody>
+          <a:bodyPr wrap="square" lIns="25400" tIns="25400" rIns="25400" bIns="25400" rtlCol="0" anchor="t">
+            <a:normAutofit/>
+          </a:bodyPr>
+          <a:lstStyle/>
+          <a:p>
+            <a:pPr marL="0" indent="0" algn="l">
+              <a:buNone/>
+            </a:pPr>
+            <a:r>
+              <a:rPr lang="en-US" sz="1600" b="1" kern="0" dirty="0">
+                <a:solidFill>
+                  <a:srgbClr val="8FBBA6"/>
+                </a:solidFill>
+                <a:latin typeface="Arial" pitchFamily="34" charset="0"/>
+                <a:ea typeface="Arial" pitchFamily="34" charset="-122"/>
+                <a:cs typeface="Arial" pitchFamily="34" charset="-120"/>
+              </a:rPr>
+              <a:t>El guion de esta presentación.</a:t>
+            </a:r>
+            <a:endParaRPr lang="en-US" sz="1600" dirty="0"/>
+          </a:p>
+        </p:txBody>
+      </p:sp>
+      <p:sp>
+        <p:nvSpPr>
+          <p:cNvPr id="27" name="Shape 27"/>
           <p:cNvSpPr/>
           <p:nvPr/>
         </p:nvSpPr>
@@ -15562,7 +15786,7 @@
       </p:sp>
       <p:sp>
         <p:nvSpPr>
-          <p:cNvPr id="22" name="Shape 22"/>
+          <p:cNvPr id="28" name="Shape 28"/>
           <p:cNvSpPr/>
           <p:nvPr/>
         </p:nvSpPr>
@@ -15590,7 +15814,7 @@
       </p:sp>
       <p:sp>
         <p:nvSpPr>
-          <p:cNvPr id="23" name="Text 23"/>
+          <p:cNvPr id="29" name="Text 29"/>
           <p:cNvSpPr/>
           <p:nvPr/>
         </p:nvSpPr>
@@ -15631,7 +15855,7 @@
       </p:sp>
       <p:sp>
         <p:nvSpPr>
-          <p:cNvPr id="24" name="Text 24"/>
+          <p:cNvPr id="30" name="Text 30"/>
           <p:cNvSpPr/>
           <p:nvPr/>
         </p:nvSpPr>
@@ -15672,7 +15896,7 @@
       </p:sp>
       <p:sp>
         <p:nvSpPr>
-          <p:cNvPr id="25" name="Text 25"/>
+          <p:cNvPr id="31" name="Text 31"/>
           <p:cNvSpPr/>
           <p:nvPr/>
         </p:nvSpPr>
@@ -15716,7 +15940,7 @@
       </p:sp>
       <p:sp>
         <p:nvSpPr>
-          <p:cNvPr id="26" name="Text 26"/>
+          <p:cNvPr id="32" name="Text 32"/>
           <p:cNvSpPr/>
           <p:nvPr/>
         </p:nvSpPr>
@@ -15760,7 +15984,7 @@
       </p:sp>
       <p:sp>
         <p:nvSpPr>
-          <p:cNvPr id="27" name="Text 27"/>
+          <p:cNvPr id="33" name="Text 33"/>
           <p:cNvSpPr/>
           <p:nvPr/>
         </p:nvSpPr>
@@ -15804,7 +16028,117 @@
       </p:sp>
       <p:sp>
         <p:nvSpPr>
-          <p:cNvPr id="28" name="Shape 28"/>
+          <p:cNvPr id="34" name="Shape 34"/>
+          <p:cNvSpPr/>
+          <p:nvPr/>
+        </p:nvSpPr>
+        <p:spPr>
+          <a:xfrm>
+            <a:off x="1066800" y="8352676"/>
+            <a:ext cx="16154400" cy="947737"/>
+          </a:xfrm>
+          <a:prstGeom prst="roundRect">
+            <a:avLst>
+              <a:gd name="adj" fmla="val 3770"/>
+            </a:avLst>
+          </a:prstGeom>
+          <a:solidFill>
+            <a:srgbClr val="ECE7DC"/>
+          </a:solidFill>
+          <a:ln/>
+          <a:effectLst/>
+        </p:spPr>
+        <p:txBody>
+          <a:bodyPr/>
+          <a:lstStyle/>
+          <a:p>
+            <a:endParaRPr lang="es-ES"/>
+          </a:p>
+        </p:txBody>
+      </p:sp>
+      <p:sp>
+        <p:nvSpPr>
+          <p:cNvPr id="35" name="Shape 35"/>
+          <p:cNvSpPr/>
+          <p:nvPr/>
+        </p:nvSpPr>
+        <p:spPr>
+          <a:xfrm>
+            <a:off x="1066800" y="8352676"/>
+            <a:ext cx="57150" cy="947737"/>
+          </a:xfrm>
+          <a:prstGeom prst="rect">
+            <a:avLst/>
+          </a:prstGeom>
+          <a:solidFill>
+            <a:srgbClr val="2D7A55"/>
+          </a:solidFill>
+          <a:ln/>
+          <a:effectLst/>
+        </p:spPr>
+        <p:txBody>
+          <a:bodyPr/>
+          <a:lstStyle/>
+          <a:p>
+            <a:endParaRPr lang="es-ES"/>
+          </a:p>
+        </p:txBody>
+      </p:sp>
+      <p:sp>
+        <p:nvSpPr>
+          <p:cNvPr id="36" name="Text 36"/>
+          <p:cNvSpPr/>
+          <p:nvPr/>
+        </p:nvSpPr>
+        <p:spPr>
+          <a:xfrm>
+            <a:off x="1447800" y="8352676"/>
+            <a:ext cx="15934182" cy="947737"/>
+          </a:xfrm>
+          <a:prstGeom prst="rect">
+            <a:avLst/>
+          </a:prstGeom>
+          <a:noFill/>
+          <a:ln/>
+        </p:spPr>
+        <p:txBody>
+          <a:bodyPr wrap="square" lIns="25400" tIns="25400" rIns="25400" bIns="25400" rtlCol="0" anchor="ctr">
+            <a:normAutofit/>
+          </a:bodyPr>
+          <a:lstStyle/>
+          <a:p>
+            <a:pPr marL="0" indent="0" algn="l">
+              <a:buNone/>
+            </a:pPr>
+            <a:r>
+              <a:rPr lang="en-US" sz="1950" b="1" kern="0" dirty="0">
+                <a:solidFill>
+                  <a:srgbClr val="0F1D18"/>
+                </a:solidFill>
+                <a:latin typeface="Arial" pitchFamily="34" charset="0"/>
+                <a:ea typeface="Arial" pitchFamily="34" charset="-122"/>
+                <a:cs typeface="Arial" pitchFamily="34" charset="-120"/>
+              </a:rPr>
+              <a:t>Las dos palancas marcan el guion a partir de aquí: </a:t>
+            </a:r>
+            <a:r>
+              <a:rPr lang="en-US" sz="1950" kern="0" dirty="0">
+                <a:solidFill>
+                  <a:srgbClr val="2A3A33"/>
+                </a:solidFill>
+                <a:latin typeface="Arial" pitchFamily="34" charset="0"/>
+                <a:ea typeface="Arial" pitchFamily="34" charset="-122"/>
+                <a:cs typeface="Arial" pitchFamily="34" charset="-120"/>
+              </a:rPr>
+              <a:t>primero la productividad; cuando se agota, las áreas.</a:t>
+            </a:r>
+            <a:endParaRPr lang="en-US" sz="1950" dirty="0"/>
+          </a:p>
+        </p:txBody>
+      </p:sp>
+      <p:sp>
+        <p:nvSpPr>
+          <p:cNvPr id="37" name="Shape 37"/>
           <p:cNvSpPr/>
           <p:nvPr/>
         </p:nvSpPr>
@@ -15834,7 +16168,7 @@
       </p:sp>
       <p:sp>
         <p:nvSpPr>
-          <p:cNvPr id="29" name="Shape 29"/>
+          <p:cNvPr id="38" name="Shape 38"/>
           <p:cNvSpPr/>
           <p:nvPr/>
         </p:nvSpPr>
@@ -15864,7 +16198,7 @@
       </p:sp>
       <p:sp>
         <p:nvSpPr>
-          <p:cNvPr id="30" name="Shape 30"/>
+          <p:cNvPr id="39" name="Shape 39"/>
           <p:cNvSpPr/>
           <p:nvPr/>
         </p:nvSpPr>
@@ -15894,7 +16228,7 @@
       </p:sp>
       <p:sp>
         <p:nvSpPr>
-          <p:cNvPr id="31" name="Shape 31"/>
+          <p:cNvPr id="40" name="Shape 40"/>
           <p:cNvSpPr/>
           <p:nvPr/>
         </p:nvSpPr>
@@ -15924,7 +16258,7 @@
       </p:sp>
       <p:sp>
         <p:nvSpPr>
-          <p:cNvPr id="32" name="Shape 32"/>
+          <p:cNvPr id="41" name="Shape 41"/>
           <p:cNvSpPr/>
           <p:nvPr/>
         </p:nvSpPr>
@@ -15954,7 +16288,7 @@
       </p:sp>
       <p:sp>
         <p:nvSpPr>
-          <p:cNvPr id="33" name="Shape 33"/>
+          <p:cNvPr id="42" name="Shape 42"/>
           <p:cNvSpPr/>
           <p:nvPr/>
         </p:nvSpPr>
@@ -15984,7 +16318,7 @@
       </p:sp>
       <p:sp>
         <p:nvSpPr>
-          <p:cNvPr id="34" name="Shape 34"/>
+          <p:cNvPr id="43" name="Shape 43"/>
           <p:cNvSpPr/>
           <p:nvPr/>
         </p:nvSpPr>
@@ -16080,7 +16414,7 @@
                 <a:ea typeface="Courier New" pitchFamily="34" charset="-122"/>
                 <a:cs typeface="Courier New" pitchFamily="34" charset="-120"/>
               </a:rPr>
-              <a:t>ANTES DE SEGUIR</a:t>
+              <a:t>ANTES DE LA PRIMERA PALANCA</a:t>
             </a:r>
             <a:endParaRPr lang="en-US" sz="1800" dirty="0"/>
           </a:p>
@@ -16955,6 +17289,61 @@
           <a:lstStyle/>
           <a:p>
             <a:endParaRPr lang="es-ES"/>
+          </a:p>
+        </p:txBody>
+      </p:sp>
+      <p:sp>
+        <p:nvSpPr>
+          <p:cNvPr id="201" name="Text 201"/>
+          <p:cNvSpPr/>
+          <p:nvPr/>
+        </p:nvSpPr>
+        <p:spPr>
+          <a:xfrm>
+            <a:off x="1066800" y="6500000"/>
+            <a:ext cx="16639032" cy="700000"/>
+          </a:xfrm>
+          <a:prstGeom prst="rect">
+            <a:avLst/>
+          </a:prstGeom>
+          <a:noFill/>
+          <a:ln/>
+        </p:spPr>
+        <p:txBody>
+          <a:bodyPr wrap="square" lIns="25400" tIns="25400" rIns="25400" bIns="25400" rtlCol="0" anchor="t">
+            <a:normAutofit/>
+          </a:bodyPr>
+          <a:lstStyle/>
+          <a:p>
+            <a:pPr marL="0" indent="0" algn="l">
+              <a:lnSpc>
+                <a:spcPct val="145000"/>
+              </a:lnSpc>
+              <a:buNone/>
+            </a:pPr>
+            <a:r>
+              <a:rPr lang="en-US" sz="2250" kern="0" dirty="0">
+                <a:solidFill>
+                  <a:srgbClr val="6A7A72"/>
+                </a:solidFill>
+                <a:latin typeface="Arial" pitchFamily="34" charset="0"/>
+                <a:ea typeface="Arial" pitchFamily="34" charset="-122"/>
+                <a:cs typeface="Arial" pitchFamily="34" charset="-120"/>
+              </a:rPr>
+              <a:t>Importa porque la productividad no se ajusta en bloque: </a:t>
+            </a:r>
+            <a:r>
+              <a:rPr lang="en-US" sz="2250" b="1" kern="0" dirty="0">
+                <a:solidFill>
+                  <a:srgbClr val="0F1D18"/>
+                </a:solidFill>
+                <a:latin typeface="Arial" pitchFamily="34" charset="0"/>
+                <a:ea typeface="Arial" pitchFamily="34" charset="-122"/>
+                <a:cs typeface="Arial" pitchFamily="34" charset="-120"/>
+              </a:rPr>
+              <a:t>se toca operativa a operativa.</a:t>
+            </a:r>
+            <a:endParaRPr lang="en-US" sz="2250" dirty="0"/>
           </a:p>
         </p:txBody>
       </p:sp>
@@ -17026,7 +17415,7 @@
                 <a:ea typeface="Courier New" pitchFamily="34" charset="-122"/>
                 <a:cs typeface="Courier New" pitchFamily="34" charset="-120"/>
               </a:rPr>
-              <a:t>BLOQUE 1 · PRODUCTIVIDAD</a:t>
+              <a:t>PALANCA 1 · PRODUCTIVIDAD</a:t>
             </a:r>
             <a:endParaRPr lang="en-US" sz="1800" dirty="0"/>
           </a:p>

</xml_diff>